<commit_message>
Personal Week 5 slide update, jpg of bootable pi added to Hardware/
</commit_message>
<xml_diff>
--- a/Weekly Reports/slides/1-ethan-wells.pptx
+++ b/Weekly Reports/slides/1-ethan-wells.pptx
@@ -5,7 +5,8 @@
     <p:sldMasterId id="2147483648" r:id="rId1"/>
   </p:sldMasterIdLst>
   <p:sldIdLst>
-    <p:sldId id="257" r:id="rId3"/>
+    <p:sldId id="257" r:id="rId2"/>
+    <p:sldId id="258" r:id="rId3"/>
   </p:sldIdLst>
   <p:sldSz cx="12192000" cy="6858000"/>
   <p:notesSz cx="6858000" cy="9144000"/>
@@ -259,7 +260,7 @@
           <a:p>
             <a:fld id="{752E6B35-DAD5-CF47-9E65-9CA12B499D8C}" type="datetimeFigureOut">
               <a:rPr lang="en-US" smtClean="0"/>
-              <a:t>9/14/2026</a:t>
+              <a:t>9/22/26</a:t>
             </a:fld>
             <a:endParaRPr lang="en-US"/>
           </a:p>
@@ -457,7 +458,7 @@
           <a:p>
             <a:fld id="{752E6B35-DAD5-CF47-9E65-9CA12B499D8C}" type="datetimeFigureOut">
               <a:rPr lang="en-US" smtClean="0"/>
-              <a:t>9/14/2026</a:t>
+              <a:t>9/22/26</a:t>
             </a:fld>
             <a:endParaRPr lang="en-US"/>
           </a:p>
@@ -665,7 +666,7 @@
           <a:p>
             <a:fld id="{752E6B35-DAD5-CF47-9E65-9CA12B499D8C}" type="datetimeFigureOut">
               <a:rPr lang="en-US" smtClean="0"/>
-              <a:t>9/14/2026</a:t>
+              <a:t>9/22/26</a:t>
             </a:fld>
             <a:endParaRPr lang="en-US"/>
           </a:p>
@@ -863,7 +864,7 @@
           <a:p>
             <a:fld id="{752E6B35-DAD5-CF47-9E65-9CA12B499D8C}" type="datetimeFigureOut">
               <a:rPr lang="en-US" smtClean="0"/>
-              <a:t>9/14/2026</a:t>
+              <a:t>9/22/26</a:t>
             </a:fld>
             <a:endParaRPr lang="en-US"/>
           </a:p>
@@ -1138,7 +1139,7 @@
           <a:p>
             <a:fld id="{752E6B35-DAD5-CF47-9E65-9CA12B499D8C}" type="datetimeFigureOut">
               <a:rPr lang="en-US" smtClean="0"/>
-              <a:t>9/14/2026</a:t>
+              <a:t>9/22/26</a:t>
             </a:fld>
             <a:endParaRPr lang="en-US"/>
           </a:p>
@@ -1403,7 +1404,7 @@
           <a:p>
             <a:fld id="{752E6B35-DAD5-CF47-9E65-9CA12B499D8C}" type="datetimeFigureOut">
               <a:rPr lang="en-US" smtClean="0"/>
-              <a:t>9/14/2026</a:t>
+              <a:t>9/22/26</a:t>
             </a:fld>
             <a:endParaRPr lang="en-US"/>
           </a:p>
@@ -1815,7 +1816,7 @@
           <a:p>
             <a:fld id="{752E6B35-DAD5-CF47-9E65-9CA12B499D8C}" type="datetimeFigureOut">
               <a:rPr lang="en-US" smtClean="0"/>
-              <a:t>9/14/2026</a:t>
+              <a:t>9/22/26</a:t>
             </a:fld>
             <a:endParaRPr lang="en-US"/>
           </a:p>
@@ -1956,7 +1957,7 @@
           <a:p>
             <a:fld id="{752E6B35-DAD5-CF47-9E65-9CA12B499D8C}" type="datetimeFigureOut">
               <a:rPr lang="en-US" smtClean="0"/>
-              <a:t>9/14/2026</a:t>
+              <a:t>9/22/26</a:t>
             </a:fld>
             <a:endParaRPr lang="en-US"/>
           </a:p>
@@ -2069,7 +2070,7 @@
           <a:p>
             <a:fld id="{752E6B35-DAD5-CF47-9E65-9CA12B499D8C}" type="datetimeFigureOut">
               <a:rPr lang="en-US" smtClean="0"/>
-              <a:t>9/14/2026</a:t>
+              <a:t>9/22/26</a:t>
             </a:fld>
             <a:endParaRPr lang="en-US"/>
           </a:p>
@@ -2380,7 +2381,7 @@
           <a:p>
             <a:fld id="{752E6B35-DAD5-CF47-9E65-9CA12B499D8C}" type="datetimeFigureOut">
               <a:rPr lang="en-US" smtClean="0"/>
-              <a:t>9/14/2026</a:t>
+              <a:t>9/22/26</a:t>
             </a:fld>
             <a:endParaRPr lang="en-US"/>
           </a:p>
@@ -2668,7 +2669,7 @@
           <a:p>
             <a:fld id="{752E6B35-DAD5-CF47-9E65-9CA12B499D8C}" type="datetimeFigureOut">
               <a:rPr lang="en-US" smtClean="0"/>
-              <a:t>9/14/2026</a:t>
+              <a:t>9/22/26</a:t>
             </a:fld>
             <a:endParaRPr lang="en-US"/>
           </a:p>
@@ -2909,7 +2910,7 @@
           <a:p>
             <a:fld id="{752E6B35-DAD5-CF47-9E65-9CA12B499D8C}" type="datetimeFigureOut">
               <a:rPr lang="en-US" smtClean="0"/>
-              <a:t>9/14/2026</a:t>
+              <a:t>9/22/26</a:t>
             </a:fld>
             <a:endParaRPr lang="en-US"/>
           </a:p>
@@ -3372,13 +3373,13 @@
         </p:nvSpPr>
         <p:spPr>
           <a:xfrm>
-            <a:off x="838200" y="1580298"/>
-            <a:ext cx="10515600" cy="4351338"/>
+            <a:off x="651510" y="1428750"/>
+            <a:ext cx="10702290" cy="4502886"/>
           </a:xfrm>
         </p:spPr>
         <p:txBody>
           <a:bodyPr>
-            <a:normAutofit fontScale="85000" lnSpcReduction="20000"/>
+            <a:normAutofit fontScale="62500" lnSpcReduction="20000"/>
           </a:bodyPr>
           <a:lstStyle/>
           <a:p>
@@ -3392,7 +3393,14 @@
             <a:pPr lvl="1"/>
             <a:r>
               <a:rPr dirty="0"/>
-              <a:t>Train the traffic-sign model in TensorFlow on the German dataset (GTSRB) and push the training code to the repo.</a:t>
+              <a:t>Prepare the LISA dataset (US traffic signs) for training.</a:t>
+            </a:r>
+          </a:p>
+          <a:p>
+            <a:pPr lvl="1"/>
+            <a:r>
+              <a:rPr dirty="0"/>
+              <a:t>Test the trained German-sign (GTSRB) model.</a:t>
             </a:r>
           </a:p>
           <a:p>
@@ -3400,57 +3408,48 @@
               <a:rPr b="1" dirty="0"/>
               <a:t>Progress for the week</a:t>
             </a:r>
+            <a:endParaRPr lang="en-US" dirty="0"/>
           </a:p>
           <a:p>
             <a:pPr lvl="1"/>
             <a:r>
               <a:rPr dirty="0"/>
-              <a:t>Trained a CNN on GTSRB, reaching ~95% validation accuracy.</a:t>
+              <a:t>Neither machine-learning goal was started — getting the CM5 ready for hardware testing took priority so the team has a working board to bench-test sensors on.</a:t>
             </a:r>
           </a:p>
           <a:p>
             <a:pPr lvl="1"/>
             <a:r>
               <a:rPr dirty="0"/>
-              <a:t>Committed the trained model (</a:t>
-            </a:r>
-            <a:r>
-              <a:rPr dirty="0" err="1"/>
-              <a:t>gtsrb_model.keras</a:t>
-            </a:r>
+              <a:t>Assembled the CM5 on the Compute Module 5 IO Board with the ZDE heatsink/PWM fan, CR2032 RTC cell, and 27 W USB-C power supply.</a:t>
+            </a:r>
+          </a:p>
+          <a:p>
+            <a:pPr lvl="1"/>
             <a:r>
               <a:rPr dirty="0"/>
-              <a:t>) and the training script (training.py).</a:t>
+              <a:t>Flashed Raspberry Pi OS Lite (64-bit) to the 128 GB KIOXIA NVMe SSD and booted the CM5 from M.2.</a:t>
             </a:r>
           </a:p>
           <a:p>
             <a:pPr lvl="1"/>
             <a:r>
               <a:rPr dirty="0"/>
-              <a:t>Set up a Python 3.12 environment (TensorFlow has no wheels for 3.13/3.14 yet).</a:t>
+              <a:t>Brought up headless SSH over the USB Wi-Fi dongle (the CM5 has no onboard wireless).</a:t>
             </a:r>
           </a:p>
           <a:p>
             <a:pPr lvl="1"/>
             <a:r>
               <a:rPr dirty="0"/>
-              <a:t>Ordered the CR2032 RTC battery and the KIOXIA 128 GB </a:t>
-            </a:r>
-            <a:r>
-              <a:rPr dirty="0" err="1"/>
-              <a:t>NVMe</a:t>
-            </a:r>
+              <a:t>SSH over Wi-Fi was painfully slow; traced it to the dongle’s stock driver and replaced it with a working RTL8188EUS build.</a:t>
+            </a:r>
+          </a:p>
+          <a:p>
+            <a:pPr lvl="1"/>
             <a:r>
               <a:rPr dirty="0"/>
-              <a:t> boot SSD, plus the USB </a:t>
-            </a:r>
-            <a:r>
-              <a:rPr dirty="0" err="1"/>
-              <a:t>NVMe</a:t>
-            </a:r>
-            <a:r>
-              <a:rPr dirty="0"/>
-              <a:t> enclosure to flash it — the enclosure has arrived; the SSD and battery are still in transit.</a:t>
+              <a:t>Purchased the remaining compute parts: NVMe SSD, USB NVMe enclosure, heatsink + PWM fan, 27 W power supply, CR2032 battery, and TP-Link Wi-Fi dongle.</a:t>
             </a:r>
           </a:p>
           <a:p>
@@ -3458,6 +3457,7 @@
               <a:rPr b="1" dirty="0"/>
               <a:t>Goals for next week</a:t>
             </a:r>
+            <a:endParaRPr lang="en-US" dirty="0"/>
           </a:p>
           <a:p>
             <a:pPr lvl="1"/>
@@ -3478,6 +3478,7 @@
               <a:rPr b="1" dirty="0"/>
               <a:t>Hours spent on progress</a:t>
             </a:r>
+            <a:endParaRPr lang="en-US" dirty="0"/>
           </a:p>
           <a:p>
             <a:pPr lvl="1"/>
@@ -3494,6 +3495,143 @@
         <p14:creationId xmlns:p14="http://schemas.microsoft.com/office/powerpoint/2010/main" val="2943549623"/>
       </p:ext>
     </p:extLst>
+  </p:cSld>
+  <p:clrMapOvr>
+    <a:masterClrMapping/>
+  </p:clrMapOvr>
+</p:sld>
+</file>
+
+<file path=ppt/slides/slide2.xml><?xml version="1.0" encoding="utf-8"?>
+<p:sld xmlns:a="http://schemas.openxmlformats.org/drawingml/2006/main" xmlns:r="http://schemas.openxmlformats.org/officeDocument/2006/relationships" xmlns:p="http://schemas.openxmlformats.org/presentationml/2006/main">
+  <p:cSld>
+    <p:spTree>
+      <p:nvGrpSpPr>
+        <p:cNvPr id="1" name=""/>
+        <p:cNvGrpSpPr/>
+        <p:nvPr/>
+      </p:nvGrpSpPr>
+      <p:grpSpPr>
+        <a:xfrm>
+          <a:off x="0" y="0"/>
+          <a:ext cx="0" cy="0"/>
+          <a:chOff x="0" y="0"/>
+          <a:chExt cx="0" cy="0"/>
+        </a:xfrm>
+      </p:grpSpPr>
+      <p:sp>
+        <p:nvSpPr>
+          <p:cNvPr id="2" name="Title 1"/>
+          <p:cNvSpPr>
+            <a:spLocks noGrp="1"/>
+          </p:cNvSpPr>
+          <p:nvPr>
+            <p:ph type="title"/>
+          </p:nvPr>
+        </p:nvSpPr>
+        <p:spPr/>
+        <p:txBody>
+          <a:bodyPr/>
+          <a:lstStyle/>
+          <a:p>
+            <a:r>
+              <a:t>CM5 Bring-Up</a:t>
+            </a:r>
+          </a:p>
+        </p:txBody>
+      </p:sp>
+      <p:pic>
+        <p:nvPicPr>
+          <p:cNvPr id="3" name="Picture 2" descr="cm5_io_board_week5.jpg"/>
+          <p:cNvPicPr>
+            <a:picLocks noChangeAspect="1"/>
+          </p:cNvPicPr>
+          <p:nvPr/>
+        </p:nvPicPr>
+        <p:blipFill>
+          <a:blip r:embed="rId2"/>
+          <a:stretch>
+            <a:fillRect/>
+          </a:stretch>
+        </p:blipFill>
+        <p:spPr>
+          <a:xfrm>
+            <a:off x="548640" y="1737360"/>
+            <a:ext cx="5277040" cy="4114800"/>
+          </a:xfrm>
+          <a:prstGeom prst="rect">
+            <a:avLst/>
+          </a:prstGeom>
+        </p:spPr>
+      </p:pic>
+      <p:sp>
+        <p:nvSpPr>
+          <p:cNvPr id="4" name="TextBox 3"/>
+          <p:cNvSpPr txBox="1"/>
+          <p:nvPr/>
+        </p:nvSpPr>
+        <p:spPr>
+          <a:xfrm>
+            <a:off x="6309360" y="1920240"/>
+            <a:ext cx="5394960" cy="3657600"/>
+          </a:xfrm>
+          <a:prstGeom prst="rect">
+            <a:avLst/>
+          </a:prstGeom>
+          <a:noFill/>
+        </p:spPr>
+        <p:txBody>
+          <a:bodyPr wrap="square">
+            <a:spAutoFit/>
+          </a:bodyPr>
+          <a:lstStyle/>
+          <a:p>
+            <a:pPr>
+              <a:spcAft>
+                <a:spcPts val="1000"/>
+              </a:spcAft>
+            </a:pPr>
+            <a:r>
+              <a:rPr sz="1800"/>
+              <a:t>•  CM5 seated on the Compute Module 5 IO Board</a:t>
+            </a:r>
+          </a:p>
+          <a:p>
+            <a:pPr>
+              <a:spcAft>
+                <a:spcPts val="1000"/>
+              </a:spcAft>
+            </a:pPr>
+            <a:r>
+              <a:rPr sz="1800"/>
+              <a:t>•  Heatsink + PWM fan, CR2032 RTC cell, 128 GB NVMe SSD in the M.2 slot</a:t>
+            </a:r>
+          </a:p>
+          <a:p>
+            <a:pPr>
+              <a:spcAft>
+                <a:spcPts val="1000"/>
+              </a:spcAft>
+            </a:pPr>
+            <a:r>
+              <a:rPr sz="1800"/>
+              <a:t>•  Powered by the 27 W USB-C supply; boots Raspberry Pi OS Lite (64-bit) from NVMe</a:t>
+            </a:r>
+          </a:p>
+          <a:p>
+            <a:pPr>
+              <a:spcAft>
+                <a:spcPts val="1000"/>
+              </a:spcAft>
+            </a:pPr>
+            <a:r>
+              <a:rPr sz="1800"/>
+              <a:t>•  Accessed headless over SSH through the USB Wi-Fi dongle</a:t>
+            </a:r>
+          </a:p>
+        </p:txBody>
+      </p:sp>
+    </p:spTree>
   </p:cSld>
   <p:clrMapOvr>
     <a:masterClrMapping/>

</xml_diff>

<commit_message>
setup.sh added to slides, jpg of setup.sh added to Hardware/
</commit_message>
<xml_diff>
--- a/Weekly Reports/slides/1-ethan-wells.pptx
+++ b/Weekly Reports/slides/1-ethan-wells.pptx
@@ -7,6 +7,7 @@
   <p:sldIdLst>
     <p:sldId id="257" r:id="rId2"/>
     <p:sldId id="258" r:id="rId3"/>
+    <p:sldId id="259" r:id="rId4"/>
   </p:sldIdLst>
   <p:sldSz cx="12192000" cy="6858000"/>
   <p:notesSz cx="6858000" cy="9144000"/>
@@ -3374,12 +3375,12 @@
         <p:spPr>
           <a:xfrm>
             <a:off x="651510" y="1428750"/>
-            <a:ext cx="10702290" cy="4502886"/>
+            <a:ext cx="10702290" cy="4857750"/>
           </a:xfrm>
         </p:spPr>
         <p:txBody>
           <a:bodyPr>
-            <a:normAutofit fontScale="62500" lnSpcReduction="20000"/>
+            <a:normAutofit fontScale="55000" lnSpcReduction="20000"/>
           </a:bodyPr>
           <a:lstStyle/>
           <a:p>
@@ -3392,14 +3393,14 @@
           <a:p>
             <a:pPr lvl="1"/>
             <a:r>
-              <a:rPr dirty="0"/>
+              <a:rPr sz="2900" dirty="0"/>
               <a:t>Prepare the LISA dataset (US traffic signs) for training.</a:t>
             </a:r>
           </a:p>
           <a:p>
             <a:pPr lvl="1"/>
             <a:r>
-              <a:rPr dirty="0"/>
+              <a:rPr sz="2900" dirty="0"/>
               <a:t>Test the trained German-sign (GTSRB) model.</a:t>
             </a:r>
           </a:p>
@@ -3413,42 +3414,57 @@
           <a:p>
             <a:pPr lvl="1"/>
             <a:r>
-              <a:rPr dirty="0"/>
+              <a:rPr sz="2900" dirty="0"/>
               <a:t>Neither machine-learning goal was started — getting the CM5 ready for hardware testing took priority so the team has a working board to bench-test sensors on.</a:t>
             </a:r>
           </a:p>
           <a:p>
             <a:pPr lvl="1"/>
             <a:r>
-              <a:rPr dirty="0"/>
+              <a:rPr sz="2900" dirty="0"/>
               <a:t>Assembled the CM5 on the Compute Module 5 IO Board with the ZDE heatsink/PWM fan, CR2032 RTC cell, and 27 W USB-C power supply.</a:t>
             </a:r>
           </a:p>
           <a:p>
             <a:pPr lvl="1"/>
             <a:r>
-              <a:rPr dirty="0"/>
+              <a:rPr sz="2900" dirty="0"/>
               <a:t>Flashed Raspberry Pi OS Lite (64-bit) to the 128 GB KIOXIA NVMe SSD and booted the CM5 from M.2.</a:t>
             </a:r>
           </a:p>
           <a:p>
             <a:pPr lvl="1"/>
             <a:r>
-              <a:rPr dirty="0"/>
+              <a:rPr sz="2900" dirty="0"/>
               <a:t>Brought up headless SSH over the USB Wi-Fi dongle (the CM5 has no onboard wireless).</a:t>
             </a:r>
           </a:p>
           <a:p>
             <a:pPr lvl="1"/>
             <a:r>
-              <a:rPr dirty="0"/>
+              <a:rPr sz="2900" dirty="0"/>
               <a:t>SSH over Wi-Fi was painfully slow; traced it to the dongle’s stock driver and replaced it with a working RTL8188EUS build.</a:t>
             </a:r>
           </a:p>
           <a:p>
             <a:pPr lvl="1"/>
             <a:r>
-              <a:rPr dirty="0"/>
+              <a:rPr sz="2900" dirty="0"/>
+              <a:t>Wrote setup.sh, a one-command install of the shared software prerequisites (git, python3, pip, venv) so </a:t>
+            </a:r>
+            <a:r>
+              <a:rPr lang="en-US" sz="2900" dirty="0"/>
+              <a:t>anyone can start </a:t>
+            </a:r>
+            <a:r>
+              <a:rPr sz="2900" dirty="0"/>
+              <a:t>from the same baseline.</a:t>
+            </a:r>
+          </a:p>
+          <a:p>
+            <a:pPr lvl="1"/>
+            <a:r>
+              <a:rPr sz="2900" dirty="0"/>
               <a:t>Purchased the remaining compute parts: NVMe SSD, USB NVMe enclosure, heatsink + PWM fan, 27 W power supply, CR2032 battery, and TP-Link Wi-Fi dongle.</a:t>
             </a:r>
           </a:p>
@@ -3462,14 +3478,14 @@
           <a:p>
             <a:pPr lvl="1"/>
             <a:r>
-              <a:rPr dirty="0"/>
+              <a:rPr sz="2900" dirty="0"/>
               <a:t>Prepare the LISA dataset (US traffic signs) for training.</a:t>
             </a:r>
           </a:p>
           <a:p>
             <a:pPr lvl="1"/>
             <a:r>
-              <a:rPr dirty="0"/>
+              <a:rPr sz="2900" dirty="0"/>
               <a:t>Test the trained German-sign (GTSRB) model.</a:t>
             </a:r>
           </a:p>
@@ -3483,7 +3499,7 @@
           <a:p>
             <a:pPr lvl="1"/>
             <a:r>
-              <a:rPr dirty="0"/>
+              <a:rPr sz="2900" dirty="0"/>
               <a:t>7 hours.</a:t>
             </a:r>
           </a:p>
@@ -3631,6 +3647,167 @@
           </a:p>
         </p:txBody>
       </p:sp>
+    </p:spTree>
+  </p:cSld>
+  <p:clrMapOvr>
+    <a:masterClrMapping/>
+  </p:clrMapOvr>
+</p:sld>
+</file>
+
+<file path=ppt/slides/slide3.xml><?xml version="1.0" encoding="utf-8"?>
+<p:sld xmlns:a="http://schemas.openxmlformats.org/drawingml/2006/main" xmlns:r="http://schemas.openxmlformats.org/officeDocument/2006/relationships" xmlns:p="http://schemas.openxmlformats.org/presentationml/2006/main">
+  <p:cSld>
+    <p:spTree>
+      <p:nvGrpSpPr>
+        <p:cNvPr id="1" name=""/>
+        <p:cNvGrpSpPr/>
+        <p:nvPr/>
+      </p:nvGrpSpPr>
+      <p:grpSpPr>
+        <a:xfrm>
+          <a:off x="0" y="0"/>
+          <a:ext cx="0" cy="0"/>
+          <a:chOff x="0" y="0"/>
+          <a:chExt cx="0" cy="0"/>
+        </a:xfrm>
+      </p:grpSpPr>
+      <p:sp>
+        <p:nvSpPr>
+          <p:cNvPr id="2" name="Title 1"/>
+          <p:cNvSpPr>
+            <a:spLocks noGrp="1"/>
+          </p:cNvSpPr>
+          <p:nvPr>
+            <p:ph type="title"/>
+          </p:nvPr>
+        </p:nvSpPr>
+        <p:spPr/>
+        <p:txBody>
+          <a:bodyPr/>
+          <a:lstStyle/>
+          <a:p>
+            <a:r>
+              <a:t>Development Environment Setup</a:t>
+            </a:r>
+          </a:p>
+        </p:txBody>
+      </p:sp>
+      <p:sp>
+        <p:nvSpPr>
+          <p:cNvPr id="4" name="TextBox 3"/>
+          <p:cNvSpPr txBox="1"/>
+          <p:nvPr/>
+        </p:nvSpPr>
+        <p:spPr>
+          <a:xfrm>
+            <a:off x="6400800" y="1920240"/>
+            <a:ext cx="5303520" cy="2970044"/>
+          </a:xfrm>
+          <a:prstGeom prst="rect">
+            <a:avLst/>
+          </a:prstGeom>
+          <a:noFill/>
+        </p:spPr>
+        <p:txBody>
+          <a:bodyPr wrap="square">
+            <a:spAutoFit/>
+          </a:bodyPr>
+          <a:lstStyle/>
+          <a:p>
+            <a:pPr>
+              <a:spcAft>
+                <a:spcPts val="1000"/>
+              </a:spcAft>
+            </a:pPr>
+            <a:r>
+              <a:rPr sz="1800" dirty="0"/>
+              <a:t>•  Wrote </a:t>
+            </a:r>
+            <a:r>
+              <a:rPr sz="1800" dirty="0" err="1"/>
+              <a:t>setup.sh</a:t>
+            </a:r>
+            <a:r>
+              <a:rPr sz="1800" dirty="0"/>
+              <a:t> so </a:t>
+            </a:r>
+            <a:r>
+              <a:rPr lang="en-US" sz="1800" dirty="0"/>
+              <a:t>anyone </a:t>
+            </a:r>
+            <a:r>
+              <a:rPr sz="1800" dirty="0"/>
+              <a:t>can bring a board to the same baseline with one command</a:t>
+            </a:r>
+          </a:p>
+          <a:p>
+            <a:pPr>
+              <a:spcAft>
+                <a:spcPts val="1000"/>
+              </a:spcAft>
+            </a:pPr>
+            <a:r>
+              <a:rPr sz="1800" dirty="0"/>
+              <a:t>•  Installs the shared prerequisites: git, python3, pip, and </a:t>
+            </a:r>
+            <a:r>
+              <a:rPr sz="1800" dirty="0" err="1"/>
+              <a:t>venv</a:t>
+            </a:r>
+            <a:r>
+              <a:rPr lang="en-US" sz="1800" dirty="0"/>
+              <a:t> </a:t>
+            </a:r>
+          </a:p>
+          <a:p>
+            <a:pPr>
+              <a:spcAft>
+                <a:spcPts val="1000"/>
+              </a:spcAft>
+            </a:pPr>
+            <a:r>
+              <a:rPr sz="1800" dirty="0"/>
+              <a:t>•  Prints the git and python3 versions at the end to confirm the install worked</a:t>
+            </a:r>
+          </a:p>
+          <a:p>
+            <a:pPr>
+              <a:spcAft>
+                <a:spcPts val="1000"/>
+              </a:spcAft>
+            </a:pPr>
+            <a:r>
+              <a:rPr sz="1800" dirty="0"/>
+              <a:t>•  Hardware-specific and runtime libraries (camera, GPIO, TensorFlow Lite) get added as the project needs them</a:t>
+            </a:r>
+          </a:p>
+        </p:txBody>
+      </p:sp>
+      <p:pic>
+        <p:nvPicPr>
+          <p:cNvPr id="5" name="Picture 4" descr="setup_sh.png"/>
+          <p:cNvPicPr>
+            <a:picLocks noChangeAspect="1"/>
+          </p:cNvPicPr>
+          <p:nvPr/>
+        </p:nvPicPr>
+        <p:blipFill>
+          <a:blip r:embed="rId3"/>
+          <a:stretch>
+            <a:fillRect/>
+          </a:stretch>
+        </p:blipFill>
+        <p:spPr>
+          <a:xfrm>
+            <a:off x="548640" y="2103120"/>
+            <a:ext cx="5486400" cy="3266902"/>
+          </a:xfrm>
+          <a:prstGeom prst="rect">
+            <a:avLst/>
+          </a:prstGeom>
+        </p:spPr>
+      </p:pic>
     </p:spTree>
   </p:cSld>
   <p:clrMapOvr>

</xml_diff>